<commit_message>
Folie 6: Textüberlappung behoben
Co-Authored-By: Claude Sonnet 5.5 <noreply@anthropic.com>
Claude-Session: https://claude.ai/code/session_01FgB7we8XF2bWXv4nWDrzG8
</commit_message>
<xml_diff>
--- a/output/v2/praesentation.pptx
+++ b/output/v2/praesentation.pptx
@@ -28854,8 +28854,8 @@
         </p:nvSpPr>
         <p:spPr>
           <a:xfrm>
-            <a:off x="6583680" y="2834640"/>
-            <a:ext cx="5212080" cy="640080"/>
+            <a:off x="4754880" y="2788920"/>
+            <a:ext cx="7040880" cy="457200"/>
           </a:xfrm>
           <a:prstGeom prst="rect">
             <a:avLst/>

</xml_diff>